<commit_message>
update - hit timer
</commit_message>
<xml_diff>
--- a/docs/EFK_Presentation.pptx
+++ b/docs/EFK_Presentation.pptx
@@ -8201,27 +8201,6 @@
                 <a:ea typeface="Calibri" pitchFamily="34" charset="-122"/>
                 <a:cs typeface="Calibri" pitchFamily="34" charset="-120"/>
               </a:rPr>
-              <a:t>Puzzle doors linked to floor switches</a:t>
-            </a:r>
-            <a:endParaRPr lang="en-US" sz="1100" dirty="0"/>
-          </a:p>
-          <a:p>
-            <a:pPr marL="342900" indent="-342900">
-              <a:spcAft>
-                <a:spcPts val="300"/>
-              </a:spcAft>
-              <a:buSzPct val="100000"/>
-              <a:buChar char="•"/>
-            </a:pPr>
-            <a:r>
-              <a:rPr lang="en-US" sz="1100" dirty="0">
-                <a:solidFill>
-                  <a:srgbClr val="F0F0F0"/>
-                </a:solidFill>
-                <a:latin typeface="Calibri" pitchFamily="34" charset="0"/>
-                <a:ea typeface="Calibri" pitchFamily="34" charset="-122"/>
-                <a:cs typeface="Calibri" pitchFamily="34" charset="-120"/>
-              </a:rPr>
               <a:t>Door swing animation (180°/sec)</a:t>
             </a:r>
             <a:endParaRPr lang="en-US" sz="1100" dirty="0"/>
@@ -10177,7 +10156,7 @@
               <a:buNone/>
             </a:pPr>
             <a:r>
-              <a:rPr lang="en-US" sz="1100" dirty="0">
+              <a:rPr lang="en-US" sz="1100" dirty="0" err="1">
                 <a:solidFill>
                   <a:srgbClr val="F0F0F0"/>
                 </a:solidFill>
@@ -10185,7 +10164,7 @@
                 <a:ea typeface="Consolas" pitchFamily="34" charset="-122"/>
                 <a:cs typeface="Consolas" pitchFamily="34" charset="-120"/>
               </a:rPr>
-              <a:t>CombatSystem</a:t>
+              <a:t>HitTimerSystem</a:t>
             </a:r>
             <a:endParaRPr lang="en-US" sz="1100" dirty="0"/>
           </a:p>
@@ -10321,7 +10300,7 @@
               <a:buNone/>
             </a:pPr>
             <a:r>
-              <a:rPr lang="en-US" sz="1100" dirty="0">
+              <a:rPr lang="en-US" sz="1100" dirty="0" err="1">
                 <a:solidFill>
                   <a:srgbClr val="F0F0F0"/>
                 </a:solidFill>
@@ -10329,7 +10308,7 @@
                 <a:ea typeface="Consolas" pitchFamily="34" charset="-122"/>
                 <a:cs typeface="Consolas" pitchFamily="34" charset="-120"/>
               </a:rPr>
-              <a:t>SwitchTriggerSystem</a:t>
+              <a:t>DoorSystem</a:t>
             </a:r>
             <a:endParaRPr lang="en-US" sz="1100" dirty="0"/>
           </a:p>
@@ -10368,7 +10347,7 @@
                 <a:ea typeface="Calibri" pitchFamily="34" charset="-122"/>
                 <a:cs typeface="Calibri" pitchFamily="34" charset="-120"/>
               </a:rPr>
-              <a:t>Check floor switches</a:t>
+              <a:t>Door action system</a:t>
             </a:r>
             <a:endParaRPr lang="en-US" sz="900" dirty="0"/>
           </a:p>
@@ -10461,11 +10440,8 @@
           <a:bodyPr wrap="square" lIns="0" tIns="0" rIns="0" bIns="0" rtlCol="0" anchor="ctr"/>
           <a:lstStyle/>
           <a:p>
-            <a:pPr marL="0" indent="0">
-              <a:buNone/>
-            </a:pPr>
-            <a:r>
-              <a:rPr lang="en-US" sz="1100" dirty="0">
+            <a:r>
+              <a:rPr lang="en-US" sz="1100" dirty="0" err="1">
                 <a:solidFill>
                   <a:srgbClr val="F0F0F0"/>
                 </a:solidFill>
@@ -10473,7 +10449,7 @@
                 <a:ea typeface="Consolas" pitchFamily="34" charset="-122"/>
                 <a:cs typeface="Consolas" pitchFamily="34" charset="-120"/>
               </a:rPr>
-              <a:t>DoorSystem + DoorPuzzleSystem</a:t>
+              <a:t>LifetimeSystem</a:t>
             </a:r>
             <a:endParaRPr lang="en-US" sz="1100" dirty="0"/>
           </a:p>
@@ -10500,9 +10476,6 @@
           <a:bodyPr wrap="square" lIns="0" tIns="0" rIns="0" bIns="0" rtlCol="0" anchor="ctr"/>
           <a:lstStyle/>
           <a:p>
-            <a:pPr marL="0" indent="0">
-              <a:buNone/>
-            </a:pPr>
             <a:r>
               <a:rPr lang="en-US" sz="900" dirty="0">
                 <a:solidFill>
@@ -10512,7 +10485,7 @@
                 <a:ea typeface="Calibri" pitchFamily="34" charset="-122"/>
                 <a:cs typeface="Calibri" pitchFamily="34" charset="-120"/>
               </a:rPr>
-              <a:t>Doors, puzzles + SFX</a:t>
+              <a:t>Destroy expired entities</a:t>
             </a:r>
             <a:endParaRPr lang="en-US" sz="900" dirty="0"/>
           </a:p>
@@ -10605,11 +10578,8 @@
           <a:bodyPr wrap="square" lIns="0" tIns="0" rIns="0" bIns="0" rtlCol="0" anchor="ctr"/>
           <a:lstStyle/>
           <a:p>
-            <a:pPr marL="0" indent="0">
-              <a:buNone/>
-            </a:pPr>
-            <a:r>
-              <a:rPr lang="en-US" sz="1100" dirty="0">
+            <a:r>
+              <a:rPr lang="en-US" sz="1100" dirty="0" err="1">
                 <a:solidFill>
                   <a:srgbClr val="F0F0F0"/>
                 </a:solidFill>
@@ -10617,7 +10587,7 @@
                 <a:ea typeface="Consolas" pitchFamily="34" charset="-122"/>
                 <a:cs typeface="Consolas" pitchFamily="34" charset="-120"/>
               </a:rPr>
-              <a:t>LifetimeSystem</a:t>
+              <a:t>CameraFollowSystem</a:t>
             </a:r>
             <a:endParaRPr lang="en-US" sz="1100" dirty="0"/>
           </a:p>
@@ -10631,22 +10601,19 @@
         </p:nvSpPr>
         <p:spPr>
           <a:xfrm>
-            <a:off x="5074920" y="3822192"/>
-            <a:ext cx="2286000" cy="182880"/>
-          </a:xfrm>
-          <a:prstGeom prst="rect">
-            <a:avLst/>
-          </a:prstGeom>
-          <a:noFill/>
-          <a:ln/>
-        </p:spPr>
-        <p:txBody>
-          <a:bodyPr wrap="square" lIns="0" tIns="0" rIns="0" bIns="0" rtlCol="0" anchor="ctr"/>
-          <a:lstStyle/>
-          <a:p>
-            <a:pPr marL="0" indent="0">
-              <a:buNone/>
-            </a:pPr>
+            <a:off x="5074920" y="3867912"/>
+            <a:ext cx="2286000" cy="128016"/>
+          </a:xfrm>
+          <a:prstGeom prst="rect">
+            <a:avLst/>
+          </a:prstGeom>
+          <a:noFill/>
+          <a:ln/>
+        </p:spPr>
+        <p:txBody>
+          <a:bodyPr wrap="square" lIns="0" tIns="0" rIns="0" bIns="0" rtlCol="0" anchor="ctr"/>
+          <a:lstStyle/>
+          <a:p>
             <a:r>
               <a:rPr lang="en-US" sz="900" dirty="0">
                 <a:solidFill>
@@ -10656,7 +10623,18 @@
                 <a:ea typeface="Calibri" pitchFamily="34" charset="-122"/>
                 <a:cs typeface="Calibri" pitchFamily="34" charset="-120"/>
               </a:rPr>
-              <a:t>Destroy expired entities</a:t>
+              <a:t>Update camera + </a:t>
+            </a:r>
+            <a:r>
+              <a:rPr lang="en-US" sz="900" dirty="0" err="1">
+                <a:solidFill>
+                  <a:srgbClr val="8899AA"/>
+                </a:solidFill>
+                <a:latin typeface="Calibri" pitchFamily="34" charset="0"/>
+                <a:ea typeface="Calibri" pitchFamily="34" charset="-122"/>
+                <a:cs typeface="Calibri" pitchFamily="34" charset="-120"/>
+              </a:rPr>
+              <a:t>AudioEventQueue</a:t>
             </a:r>
             <a:endParaRPr lang="en-US" sz="900" dirty="0"/>
           </a:p>
@@ -10753,17 +10731,18 @@
               <a:buNone/>
             </a:pPr>
             <a:r>
-              <a:rPr lang="en-US" sz="1100" dirty="0">
-                <a:solidFill>
-                  <a:srgbClr val="F0F0F0"/>
-                </a:solidFill>
-                <a:latin typeface="Consolas" pitchFamily="34" charset="0"/>
-                <a:ea typeface="Consolas" pitchFamily="34" charset="-122"/>
-                <a:cs typeface="Consolas" pitchFamily="34" charset="-120"/>
-              </a:rPr>
-              <a:t>CameraFollowSystem</a:t>
-            </a:r>
-            <a:endParaRPr lang="en-US" sz="1100" dirty="0"/>
+              <a:rPr lang="en-US" sz="1100" dirty="0" err="1">
+                <a:solidFill>
+                  <a:schemeClr val="bg1"/>
+                </a:solidFill>
+              </a:rPr>
+              <a:t>AudioEventQueue</a:t>
+            </a:r>
+            <a:endParaRPr lang="en-US" sz="1100" dirty="0">
+              <a:solidFill>
+                <a:schemeClr val="bg1"/>
+              </a:solidFill>
+            </a:endParaRPr>
           </a:p>
         </p:txBody>
       </p:sp>
@@ -10775,7 +10754,7 @@
         </p:nvSpPr>
         <p:spPr>
           <a:xfrm>
-            <a:off x="5074920" y="4325112"/>
+            <a:off x="5074920" y="4321796"/>
             <a:ext cx="2286000" cy="182880"/>
           </a:xfrm>
           <a:prstGeom prst="rect">
@@ -10788,9 +10767,6 @@
           <a:bodyPr wrap="square" lIns="0" tIns="0" rIns="0" bIns="0" rtlCol="0" anchor="ctr"/>
           <a:lstStyle/>
           <a:p>
-            <a:pPr marL="0" indent="0">
-              <a:buNone/>
-            </a:pPr>
             <a:r>
               <a:rPr lang="en-US" sz="900" dirty="0">
                 <a:solidFill>
@@ -10800,9 +10776,15 @@
                 <a:ea typeface="Calibri" pitchFamily="34" charset="-122"/>
                 <a:cs typeface="Calibri" pitchFamily="34" charset="-120"/>
               </a:rPr>
-              <a:t>Update camera + AudioEventQueue</a:t>
-            </a:r>
-            <a:endParaRPr lang="en-US" sz="900" dirty="0"/>
+              <a:t>Play Audio</a:t>
+            </a:r>
+            <a:endParaRPr lang="en-US" sz="900" dirty="0">
+              <a:solidFill>
+                <a:schemeClr val="bg1">
+                  <a:lumMod val="75000"/>
+                </a:schemeClr>
+              </a:solidFill>
+            </a:endParaRPr>
           </a:p>
         </p:txBody>
       </p:sp>

</xml_diff>